<commit_message>
Add Slide 8: real task token comparison for User Login Dashboard
Shows side-by-side token breakdown (system prompt, file context,
output, tool calls) and estimated cost for Web (Opus 4.8) vs IDE
(Sonnet 4.6) including prompt cache savings and repeat-run costs.

Co-Authored-By: Claude Sonnet 4.6 <noreply@anthropic.com>
Claude-Session: https://claude.ai/code/session_01FUA8ft4DSU8QYhBZ2VWQM3
</commit_message>
<xml_diff>
--- a/Claude_Web_vs_IDE.pptx
+++ b/Claude_Web_vs_IDE.pptx
@@ -12,6 +12,7 @@
     <p:sldId id="260" r:id="rId11"/>
     <p:sldId id="261" r:id="rId12"/>
     <p:sldId id="262" r:id="rId13"/>
+    <p:sldId id="263" r:id="rId14"/>
   </p:sldIdLst>
   <p:sldSz cx="12188952" cy="6858000" type="screen4x3"/>
   <p:notesSz cx="6858000" cy="9144000"/>
@@ -9638,6 +9639,2715 @@
                 </a:solidFill>
               </a:rPr>
               <a:t>Always enable: Adaptive Thinking  ·  Prompt Caching  ·  Streaming  ·  Token Count API before large calls</a:t>
+            </a:r>
+          </a:p>
+        </p:txBody>
+      </p:sp>
+    </p:spTree>
+  </p:cSld>
+  <p:clrMapOvr>
+    <a:masterClrMapping/>
+  </p:clrMapOvr>
+</p:sld>
+</file>
+
+<file path=ppt/slides/slide8.xml><?xml version="1.0" encoding="utf-8"?>
+<p:sld xmlns:a="http://schemas.openxmlformats.org/drawingml/2006/main" xmlns:p="http://schemas.openxmlformats.org/presentationml/2006/main" xmlns:r="http://schemas.openxmlformats.org/officeDocument/2006/relationships">
+  <p:cSld>
+    <p:bg>
+      <p:bgPr>
+        <a:solidFill>
+          <a:srgbClr val="0D1B2A"/>
+        </a:solidFill>
+        <a:effectLst/>
+      </p:bgPr>
+    </p:bg>
+    <p:spTree>
+      <p:nvGrpSpPr>
+        <p:cNvPr id="1" name=""/>
+        <p:cNvGrpSpPr/>
+        <p:nvPr/>
+      </p:nvGrpSpPr>
+      <p:grpSpPr/>
+      <p:sp>
+        <p:nvSpPr>
+          <p:cNvPr id="2" name="Rectangle 1"/>
+          <p:cNvSpPr/>
+          <p:nvPr/>
+        </p:nvSpPr>
+        <p:spPr>
+          <a:xfrm>
+            <a:off x="0" y="0"/>
+            <a:ext cx="12188952" cy="73152"/>
+          </a:xfrm>
+          <a:prstGeom prst="rect">
+            <a:avLst/>
+          </a:prstGeom>
+          <a:solidFill>
+            <a:srgbClr val="E88C03"/>
+          </a:solidFill>
+          <a:ln>
+            <a:noFill/>
+          </a:ln>
+        </p:spPr>
+        <p:style>
+          <a:lnRef idx="1">
+            <a:schemeClr val="accent1"/>
+          </a:lnRef>
+          <a:fillRef idx="3">
+            <a:schemeClr val="accent1"/>
+          </a:fillRef>
+          <a:effectRef idx="2">
+            <a:schemeClr val="accent1"/>
+          </a:effectRef>
+          <a:fontRef idx="minor">
+            <a:schemeClr val="lt1"/>
+          </a:fontRef>
+        </p:style>
+        <p:txBody>
+          <a:bodyPr rtlCol="0" anchor="ctr"/>
+          <a:lstStyle/>
+          <a:p>
+            <a:pPr algn="ctr"/>
+          </a:p>
+        </p:txBody>
+      </p:sp>
+      <p:sp>
+        <p:nvSpPr>
+          <p:cNvPr id="3" name="TextBox 2"/>
+          <p:cNvSpPr txBox="1"/>
+          <p:nvPr/>
+        </p:nvSpPr>
+        <p:spPr>
+          <a:xfrm>
+            <a:off x="274320" y="137160"/>
+            <a:ext cx="11430000" cy="594360"/>
+          </a:xfrm>
+          <a:prstGeom prst="rect">
+            <a:avLst/>
+          </a:prstGeom>
+          <a:noFill/>
+        </p:spPr>
+        <p:txBody>
+          <a:bodyPr wrap="square">
+            <a:spAutoFit/>
+          </a:bodyPr>
+          <a:lstStyle/>
+          <a:p>
+            <a:pPr algn="ctr"/>
+            <a:r>
+              <a:rPr sz="2400" b="1" i="0">
+                <a:solidFill>
+                  <a:srgbClr val="FFFFFF"/>
+                </a:solidFill>
+              </a:rPr>
+              <a:t>Real Task: Build a User Login Dashboard</a:t>
+            </a:r>
+          </a:p>
+        </p:txBody>
+      </p:sp>
+      <p:sp>
+        <p:nvSpPr>
+          <p:cNvPr id="4" name="TextBox 3"/>
+          <p:cNvSpPr txBox="1"/>
+          <p:nvPr/>
+        </p:nvSpPr>
+        <p:spPr>
+          <a:xfrm>
+            <a:off x="274320" y="685800"/>
+            <a:ext cx="11430000" cy="347472"/>
+          </a:xfrm>
+          <a:prstGeom prst="rect">
+            <a:avLst/>
+          </a:prstGeom>
+          <a:noFill/>
+        </p:spPr>
+        <p:txBody>
+          <a:bodyPr wrap="square">
+            <a:spAutoFit/>
+          </a:bodyPr>
+          <a:lstStyle/>
+          <a:p>
+            <a:pPr algn="ctr"/>
+            <a:r>
+              <a:rPr sz="1300" b="0" i="0">
+                <a:solidFill>
+                  <a:srgbClr val="909090"/>
+                </a:solidFill>
+              </a:rPr>
+              <a:t>Token &amp; cost breakdown for the same task on Web vs IDE</a:t>
+            </a:r>
+          </a:p>
+        </p:txBody>
+      </p:sp>
+      <p:sp>
+        <p:nvSpPr>
+          <p:cNvPr id="5" name="Rectangle 4"/>
+          <p:cNvSpPr/>
+          <p:nvPr/>
+        </p:nvSpPr>
+        <p:spPr>
+          <a:xfrm>
+            <a:off x="274320" y="1078992"/>
+            <a:ext cx="11640312" cy="530352"/>
+          </a:xfrm>
+          <a:prstGeom prst="rect">
+            <a:avLst/>
+          </a:prstGeom>
+          <a:solidFill>
+            <a:srgbClr val="1A2B3C"/>
+          </a:solidFill>
+          <a:ln w="12700">
+            <a:solidFill>
+              <a:srgbClr val="E88C03"/>
+            </a:solidFill>
+          </a:ln>
+        </p:spPr>
+        <p:style>
+          <a:lnRef idx="1">
+            <a:schemeClr val="accent1"/>
+          </a:lnRef>
+          <a:fillRef idx="3">
+            <a:schemeClr val="accent1"/>
+          </a:fillRef>
+          <a:effectRef idx="2">
+            <a:schemeClr val="accent1"/>
+          </a:effectRef>
+          <a:fontRef idx="minor">
+            <a:schemeClr val="lt1"/>
+          </a:fontRef>
+        </p:style>
+        <p:txBody>
+          <a:bodyPr rtlCol="0" anchor="ctr"/>
+          <a:lstStyle/>
+          <a:p>
+            <a:pPr algn="ctr"/>
+          </a:p>
+        </p:txBody>
+      </p:sp>
+      <p:sp>
+        <p:nvSpPr>
+          <p:cNvPr id="6" name="TextBox 5"/>
+          <p:cNvSpPr txBox="1"/>
+          <p:nvPr/>
+        </p:nvSpPr>
+        <p:spPr>
+          <a:xfrm>
+            <a:off x="457200" y="1143000"/>
+            <a:ext cx="11247120" cy="411480"/>
+          </a:xfrm>
+          <a:prstGeom prst="rect">
+            <a:avLst/>
+          </a:prstGeom>
+          <a:noFill/>
+        </p:spPr>
+        <p:txBody>
+          <a:bodyPr wrap="square">
+            <a:spAutoFit/>
+          </a:bodyPr>
+          <a:lstStyle/>
+          <a:p>
+            <a:pPr algn="l"/>
+            <a:r>
+              <a:rPr sz="1250" b="0" i="0">
+                <a:solidFill>
+                  <a:srgbClr val="E88C03"/>
+                </a:solidFill>
+              </a:rPr>
+              <a:t>📋  Task: "Create a login page with email/password form, JWT auth, session dashboard showing user info &amp; last login time"</a:t>
+            </a:r>
+          </a:p>
+        </p:txBody>
+      </p:sp>
+      <p:sp>
+        <p:nvSpPr>
+          <p:cNvPr id="7" name="Rectangle 6"/>
+          <p:cNvSpPr/>
+          <p:nvPr/>
+        </p:nvSpPr>
+        <p:spPr>
+          <a:xfrm>
+            <a:off x="274320" y="1737360"/>
+            <a:ext cx="5577840" cy="4160520"/>
+          </a:xfrm>
+          <a:prstGeom prst="rect">
+            <a:avLst/>
+          </a:prstGeom>
+          <a:solidFill>
+            <a:srgbClr val="1A2B3C"/>
+          </a:solidFill>
+          <a:ln w="19050">
+            <a:solidFill>
+              <a:srgbClr val="1E90FF"/>
+            </a:solidFill>
+          </a:ln>
+        </p:spPr>
+        <p:style>
+          <a:lnRef idx="1">
+            <a:schemeClr val="accent1"/>
+          </a:lnRef>
+          <a:fillRef idx="3">
+            <a:schemeClr val="accent1"/>
+          </a:fillRef>
+          <a:effectRef idx="2">
+            <a:schemeClr val="accent1"/>
+          </a:effectRef>
+          <a:fontRef idx="minor">
+            <a:schemeClr val="lt1"/>
+          </a:fontRef>
+        </p:style>
+        <p:txBody>
+          <a:bodyPr rtlCol="0" anchor="ctr"/>
+          <a:lstStyle/>
+          <a:p>
+            <a:pPr algn="ctr"/>
+          </a:p>
+        </p:txBody>
+      </p:sp>
+      <p:sp>
+        <p:nvSpPr>
+          <p:cNvPr id="8" name="TextBox 7"/>
+          <p:cNvSpPr txBox="1"/>
+          <p:nvPr/>
+        </p:nvSpPr>
+        <p:spPr>
+          <a:xfrm>
+            <a:off x="457200" y="1783080"/>
+            <a:ext cx="5303520" cy="411480"/>
+          </a:xfrm>
+          <a:prstGeom prst="rect">
+            <a:avLst/>
+          </a:prstGeom>
+          <a:noFill/>
+        </p:spPr>
+        <p:txBody>
+          <a:bodyPr wrap="square">
+            <a:spAutoFit/>
+          </a:bodyPr>
+          <a:lstStyle/>
+          <a:p>
+            <a:pPr algn="l"/>
+            <a:r>
+              <a:rPr sz="1400" b="1" i="0">
+                <a:solidFill>
+                  <a:srgbClr val="1E90FF"/>
+                </a:solidFill>
+              </a:rPr>
+              <a:t>🌐  Web — Claude Opus 4.8</a:t>
+            </a:r>
+          </a:p>
+        </p:txBody>
+      </p:sp>
+      <p:sp>
+        <p:nvSpPr>
+          <p:cNvPr id="9" name="Rectangle 8"/>
+          <p:cNvSpPr/>
+          <p:nvPr/>
+        </p:nvSpPr>
+        <p:spPr>
+          <a:xfrm>
+            <a:off x="292608" y="2267712"/>
+            <a:ext cx="5541264" cy="411480"/>
+          </a:xfrm>
+          <a:prstGeom prst="rect">
+            <a:avLst/>
+          </a:prstGeom>
+          <a:solidFill>
+            <a:srgbClr val="0D1B2A"/>
+          </a:solidFill>
+          <a:ln>
+            <a:noFill/>
+          </a:ln>
+        </p:spPr>
+        <p:style>
+          <a:lnRef idx="1">
+            <a:schemeClr val="accent1"/>
+          </a:lnRef>
+          <a:fillRef idx="3">
+            <a:schemeClr val="accent1"/>
+          </a:fillRef>
+          <a:effectRef idx="2">
+            <a:schemeClr val="accent1"/>
+          </a:effectRef>
+          <a:fontRef idx="minor">
+            <a:schemeClr val="lt1"/>
+          </a:fontRef>
+        </p:style>
+        <p:txBody>
+          <a:bodyPr rtlCol="0" anchor="ctr"/>
+          <a:lstStyle/>
+          <a:p>
+            <a:pPr algn="ctr"/>
+          </a:p>
+        </p:txBody>
+      </p:sp>
+      <p:sp>
+        <p:nvSpPr>
+          <p:cNvPr id="10" name="TextBox 9"/>
+          <p:cNvSpPr txBox="1"/>
+          <p:nvPr/>
+        </p:nvSpPr>
+        <p:spPr>
+          <a:xfrm>
+            <a:off x="411480" y="2313432"/>
+            <a:ext cx="3154680" cy="329184"/>
+          </a:xfrm>
+          <a:prstGeom prst="rect">
+            <a:avLst/>
+          </a:prstGeom>
+          <a:noFill/>
+        </p:spPr>
+        <p:txBody>
+          <a:bodyPr wrap="square">
+            <a:spAutoFit/>
+          </a:bodyPr>
+          <a:lstStyle/>
+          <a:p>
+            <a:pPr algn="l"/>
+            <a:r>
+              <a:rPr sz="1100" b="0" i="0">
+                <a:solidFill>
+                  <a:srgbClr val="E0E0E0"/>
+                </a:solidFill>
+              </a:rPr>
+              <a:t>System prompt (per turn)</a:t>
+            </a:r>
+          </a:p>
+        </p:txBody>
+      </p:sp>
+      <p:sp>
+        <p:nvSpPr>
+          <p:cNvPr id="11" name="TextBox 10"/>
+          <p:cNvSpPr txBox="1"/>
+          <p:nvPr/>
+        </p:nvSpPr>
+        <p:spPr>
+          <a:xfrm>
+            <a:off x="3657600" y="2313432"/>
+            <a:ext cx="1280160" cy="329184"/>
+          </a:xfrm>
+          <a:prstGeom prst="rect">
+            <a:avLst/>
+          </a:prstGeom>
+          <a:noFill/>
+        </p:spPr>
+        <p:txBody>
+          <a:bodyPr wrap="square">
+            <a:spAutoFit/>
+          </a:bodyPr>
+          <a:lstStyle/>
+          <a:p>
+            <a:pPr algn="r"/>
+            <a:r>
+              <a:rPr sz="1100" b="0" i="0">
+                <a:solidFill>
+                  <a:srgbClr val="FFFFFF"/>
+                </a:solidFill>
+              </a:rPr>
+              <a:t>~1,200 tokens</a:t>
+            </a:r>
+          </a:p>
+        </p:txBody>
+      </p:sp>
+      <p:sp>
+        <p:nvSpPr>
+          <p:cNvPr id="12" name="TextBox 11"/>
+          <p:cNvSpPr txBox="1"/>
+          <p:nvPr/>
+        </p:nvSpPr>
+        <p:spPr>
+          <a:xfrm>
+            <a:off x="4983480" y="2313432"/>
+            <a:ext cx="822960" cy="329184"/>
+          </a:xfrm>
+          <a:prstGeom prst="rect">
+            <a:avLst/>
+          </a:prstGeom>
+          <a:noFill/>
+        </p:spPr>
+        <p:txBody>
+          <a:bodyPr wrap="square">
+            <a:spAutoFit/>
+          </a:bodyPr>
+          <a:lstStyle/>
+          <a:p>
+            <a:pPr algn="l"/>
+            <a:r>
+              <a:rPr sz="900" b="0" i="0">
+                <a:solidFill>
+                  <a:srgbClr val="709070"/>
+                </a:solidFill>
+              </a:rPr>
+              <a:t>cached after 1st call</a:t>
+            </a:r>
+          </a:p>
+        </p:txBody>
+      </p:sp>
+      <p:sp>
+        <p:nvSpPr>
+          <p:cNvPr id="13" name="Rectangle 12"/>
+          <p:cNvSpPr/>
+          <p:nvPr/>
+        </p:nvSpPr>
+        <p:spPr>
+          <a:xfrm>
+            <a:off x="292608" y="2706624"/>
+            <a:ext cx="5541264" cy="411480"/>
+          </a:xfrm>
+          <a:prstGeom prst="rect">
+            <a:avLst/>
+          </a:prstGeom>
+          <a:solidFill>
+            <a:srgbClr val="122030"/>
+          </a:solidFill>
+          <a:ln>
+            <a:noFill/>
+          </a:ln>
+        </p:spPr>
+        <p:style>
+          <a:lnRef idx="1">
+            <a:schemeClr val="accent1"/>
+          </a:lnRef>
+          <a:fillRef idx="3">
+            <a:schemeClr val="accent1"/>
+          </a:fillRef>
+          <a:effectRef idx="2">
+            <a:schemeClr val="accent1"/>
+          </a:effectRef>
+          <a:fontRef idx="minor">
+            <a:schemeClr val="lt1"/>
+          </a:fontRef>
+        </p:style>
+        <p:txBody>
+          <a:bodyPr rtlCol="0" anchor="ctr"/>
+          <a:lstStyle/>
+          <a:p>
+            <a:pPr algn="ctr"/>
+          </a:p>
+        </p:txBody>
+      </p:sp>
+      <p:sp>
+        <p:nvSpPr>
+          <p:cNvPr id="14" name="TextBox 13"/>
+          <p:cNvSpPr txBox="1"/>
+          <p:nvPr/>
+        </p:nvSpPr>
+        <p:spPr>
+          <a:xfrm>
+            <a:off x="411480" y="2752344"/>
+            <a:ext cx="3154680" cy="329184"/>
+          </a:xfrm>
+          <a:prstGeom prst="rect">
+            <a:avLst/>
+          </a:prstGeom>
+          <a:noFill/>
+        </p:spPr>
+        <p:txBody>
+          <a:bodyPr wrap="square">
+            <a:spAutoFit/>
+          </a:bodyPr>
+          <a:lstStyle/>
+          <a:p>
+            <a:pPr algn="l"/>
+            <a:r>
+              <a:rPr sz="1100" b="0" i="0">
+                <a:solidFill>
+                  <a:srgbClr val="E0E0E0"/>
+                </a:solidFill>
+              </a:rPr>
+              <a:t>User prompt</a:t>
+            </a:r>
+          </a:p>
+        </p:txBody>
+      </p:sp>
+      <p:sp>
+        <p:nvSpPr>
+          <p:cNvPr id="15" name="TextBox 14"/>
+          <p:cNvSpPr txBox="1"/>
+          <p:nvPr/>
+        </p:nvSpPr>
+        <p:spPr>
+          <a:xfrm>
+            <a:off x="3657600" y="2752344"/>
+            <a:ext cx="1280160" cy="329184"/>
+          </a:xfrm>
+          <a:prstGeom prst="rect">
+            <a:avLst/>
+          </a:prstGeom>
+          <a:noFill/>
+        </p:spPr>
+        <p:txBody>
+          <a:bodyPr wrap="square">
+            <a:spAutoFit/>
+          </a:bodyPr>
+          <a:lstStyle/>
+          <a:p>
+            <a:pPr algn="r"/>
+            <a:r>
+              <a:rPr sz="1100" b="0" i="0">
+                <a:solidFill>
+                  <a:srgbClr val="FFFFFF"/>
+                </a:solidFill>
+              </a:rPr>
+              <a:t>~320 tokens</a:t>
+            </a:r>
+          </a:p>
+        </p:txBody>
+      </p:sp>
+      <p:sp>
+        <p:nvSpPr>
+          <p:cNvPr id="16" name="TextBox 15"/>
+          <p:cNvSpPr txBox="1"/>
+          <p:nvPr/>
+        </p:nvSpPr>
+        <p:spPr>
+          <a:xfrm>
+            <a:off x="4983480" y="2752344"/>
+            <a:ext cx="822960" cy="329184"/>
+          </a:xfrm>
+          <a:prstGeom prst="rect">
+            <a:avLst/>
+          </a:prstGeom>
+          <a:noFill/>
+        </p:spPr>
+        <p:txBody>
+          <a:bodyPr wrap="square">
+            <a:spAutoFit/>
+          </a:bodyPr>
+          <a:lstStyle/>
+          <a:p>
+            <a:pPr algn="l"/>
+            <a:r>
+              <a:rPr sz="900" b="0" i="0">
+                <a:solidFill>
+                  <a:srgbClr val="709070"/>
+                </a:solidFill>
+              </a:rPr>
+              <a:t>one-time</a:t>
+            </a:r>
+          </a:p>
+        </p:txBody>
+      </p:sp>
+      <p:sp>
+        <p:nvSpPr>
+          <p:cNvPr id="17" name="Rectangle 16"/>
+          <p:cNvSpPr/>
+          <p:nvPr/>
+        </p:nvSpPr>
+        <p:spPr>
+          <a:xfrm>
+            <a:off x="292608" y="3145536"/>
+            <a:ext cx="5541264" cy="411480"/>
+          </a:xfrm>
+          <a:prstGeom prst="rect">
+            <a:avLst/>
+          </a:prstGeom>
+          <a:solidFill>
+            <a:srgbClr val="0D1B2A"/>
+          </a:solidFill>
+          <a:ln>
+            <a:noFill/>
+          </a:ln>
+        </p:spPr>
+        <p:style>
+          <a:lnRef idx="1">
+            <a:schemeClr val="accent1"/>
+          </a:lnRef>
+          <a:fillRef idx="3">
+            <a:schemeClr val="accent1"/>
+          </a:fillRef>
+          <a:effectRef idx="2">
+            <a:schemeClr val="accent1"/>
+          </a:effectRef>
+          <a:fontRef idx="minor">
+            <a:schemeClr val="lt1"/>
+          </a:fontRef>
+        </p:style>
+        <p:txBody>
+          <a:bodyPr rtlCol="0" anchor="ctr"/>
+          <a:lstStyle/>
+          <a:p>
+            <a:pPr algn="ctr"/>
+          </a:p>
+        </p:txBody>
+      </p:sp>
+      <p:sp>
+        <p:nvSpPr>
+          <p:cNvPr id="18" name="TextBox 17"/>
+          <p:cNvSpPr txBox="1"/>
+          <p:nvPr/>
+        </p:nvSpPr>
+        <p:spPr>
+          <a:xfrm>
+            <a:off x="411480" y="3191256"/>
+            <a:ext cx="3154680" cy="329184"/>
+          </a:xfrm>
+          <a:prstGeom prst="rect">
+            <a:avLst/>
+          </a:prstGeom>
+          <a:noFill/>
+        </p:spPr>
+        <p:txBody>
+          <a:bodyPr wrap="square">
+            <a:spAutoFit/>
+          </a:bodyPr>
+          <a:lstStyle/>
+          <a:p>
+            <a:pPr algn="l"/>
+            <a:r>
+              <a:rPr sz="1100" b="0" i="0">
+                <a:solidFill>
+                  <a:srgbClr val="E0E0E0"/>
+                </a:solidFill>
+              </a:rPr>
+              <a:t>File context (HTML/JS/CSS)</a:t>
+            </a:r>
+          </a:p>
+        </p:txBody>
+      </p:sp>
+      <p:sp>
+        <p:nvSpPr>
+          <p:cNvPr id="19" name="TextBox 18"/>
+          <p:cNvSpPr txBox="1"/>
+          <p:nvPr/>
+        </p:nvSpPr>
+        <p:spPr>
+          <a:xfrm>
+            <a:off x="3657600" y="3191256"/>
+            <a:ext cx="1280160" cy="329184"/>
+          </a:xfrm>
+          <a:prstGeom prst="rect">
+            <a:avLst/>
+          </a:prstGeom>
+          <a:noFill/>
+        </p:spPr>
+        <p:txBody>
+          <a:bodyPr wrap="square">
+            <a:spAutoFit/>
+          </a:bodyPr>
+          <a:lstStyle/>
+          <a:p>
+            <a:pPr algn="r"/>
+            <a:r>
+              <a:rPr sz="1100" b="0" i="0">
+                <a:solidFill>
+                  <a:srgbClr val="FFFFFF"/>
+                </a:solidFill>
+              </a:rPr>
+              <a:t>~2,800 tokens</a:t>
+            </a:r>
+          </a:p>
+        </p:txBody>
+      </p:sp>
+      <p:sp>
+        <p:nvSpPr>
+          <p:cNvPr id="20" name="TextBox 19"/>
+          <p:cNvSpPr txBox="1"/>
+          <p:nvPr/>
+        </p:nvSpPr>
+        <p:spPr>
+          <a:xfrm>
+            <a:off x="4983480" y="3191256"/>
+            <a:ext cx="822960" cy="329184"/>
+          </a:xfrm>
+          <a:prstGeom prst="rect">
+            <a:avLst/>
+          </a:prstGeom>
+          <a:noFill/>
+        </p:spPr>
+        <p:txBody>
+          <a:bodyPr wrap="square">
+            <a:spAutoFit/>
+          </a:bodyPr>
+          <a:lstStyle/>
+          <a:p>
+            <a:pPr algn="l"/>
+            <a:r>
+              <a:rPr sz="900" b="0" i="0">
+                <a:solidFill>
+                  <a:srgbClr val="709070"/>
+                </a:solidFill>
+              </a:rPr>
+              <a:t>cached after 1st edit</a:t>
+            </a:r>
+          </a:p>
+        </p:txBody>
+      </p:sp>
+      <p:sp>
+        <p:nvSpPr>
+          <p:cNvPr id="21" name="Rectangle 20"/>
+          <p:cNvSpPr/>
+          <p:nvPr/>
+        </p:nvSpPr>
+        <p:spPr>
+          <a:xfrm>
+            <a:off x="292608" y="3584448"/>
+            <a:ext cx="5541264" cy="411480"/>
+          </a:xfrm>
+          <a:prstGeom prst="rect">
+            <a:avLst/>
+          </a:prstGeom>
+          <a:solidFill>
+            <a:srgbClr val="122030"/>
+          </a:solidFill>
+          <a:ln>
+            <a:noFill/>
+          </a:ln>
+        </p:spPr>
+        <p:style>
+          <a:lnRef idx="1">
+            <a:schemeClr val="accent1"/>
+          </a:lnRef>
+          <a:fillRef idx="3">
+            <a:schemeClr val="accent1"/>
+          </a:fillRef>
+          <a:effectRef idx="2">
+            <a:schemeClr val="accent1"/>
+          </a:effectRef>
+          <a:fontRef idx="minor">
+            <a:schemeClr val="lt1"/>
+          </a:fontRef>
+        </p:style>
+        <p:txBody>
+          <a:bodyPr rtlCol="0" anchor="ctr"/>
+          <a:lstStyle/>
+          <a:p>
+            <a:pPr algn="ctr"/>
+          </a:p>
+        </p:txBody>
+      </p:sp>
+      <p:sp>
+        <p:nvSpPr>
+          <p:cNvPr id="22" name="TextBox 21"/>
+          <p:cNvSpPr txBox="1"/>
+          <p:nvPr/>
+        </p:nvSpPr>
+        <p:spPr>
+          <a:xfrm>
+            <a:off x="411480" y="3630168"/>
+            <a:ext cx="3154680" cy="329184"/>
+          </a:xfrm>
+          <a:prstGeom prst="rect">
+            <a:avLst/>
+          </a:prstGeom>
+          <a:noFill/>
+        </p:spPr>
+        <p:txBody>
+          <a:bodyPr wrap="square">
+            <a:spAutoFit/>
+          </a:bodyPr>
+          <a:lstStyle/>
+          <a:p>
+            <a:pPr algn="l"/>
+            <a:r>
+              <a:rPr sz="1100" b="0" i="0">
+                <a:solidFill>
+                  <a:srgbClr val="E0E0E0"/>
+                </a:solidFill>
+              </a:rPr>
+              <a:t>Model output (code + explain)</a:t>
+            </a:r>
+          </a:p>
+        </p:txBody>
+      </p:sp>
+      <p:sp>
+        <p:nvSpPr>
+          <p:cNvPr id="23" name="TextBox 22"/>
+          <p:cNvSpPr txBox="1"/>
+          <p:nvPr/>
+        </p:nvSpPr>
+        <p:spPr>
+          <a:xfrm>
+            <a:off x="3657600" y="3630168"/>
+            <a:ext cx="1280160" cy="329184"/>
+          </a:xfrm>
+          <a:prstGeom prst="rect">
+            <a:avLst/>
+          </a:prstGeom>
+          <a:noFill/>
+        </p:spPr>
+        <p:txBody>
+          <a:bodyPr wrap="square">
+            <a:spAutoFit/>
+          </a:bodyPr>
+          <a:lstStyle/>
+          <a:p>
+            <a:pPr algn="r"/>
+            <a:r>
+              <a:rPr sz="1100" b="0" i="0">
+                <a:solidFill>
+                  <a:srgbClr val="FFFFFF"/>
+                </a:solidFill>
+              </a:rPr>
+              <a:t>~3,500 tokens</a:t>
+            </a:r>
+          </a:p>
+        </p:txBody>
+      </p:sp>
+      <p:sp>
+        <p:nvSpPr>
+          <p:cNvPr id="24" name="TextBox 23"/>
+          <p:cNvSpPr txBox="1"/>
+          <p:nvPr/>
+        </p:nvSpPr>
+        <p:spPr>
+          <a:xfrm>
+            <a:off x="4983480" y="3630168"/>
+            <a:ext cx="822960" cy="329184"/>
+          </a:xfrm>
+          <a:prstGeom prst="rect">
+            <a:avLst/>
+          </a:prstGeom>
+          <a:noFill/>
+        </p:spPr>
+        <p:txBody>
+          <a:bodyPr wrap="square">
+            <a:spAutoFit/>
+          </a:bodyPr>
+          <a:lstStyle/>
+          <a:p>
+            <a:pPr algn="l"/>
+            <a:r>
+              <a:rPr sz="900" b="0" i="0">
+                <a:solidFill>
+                  <a:srgbClr val="709070"/>
+                </a:solidFill>
+              </a:rPr>
+              <a:t>output, billed full</a:t>
+            </a:r>
+          </a:p>
+        </p:txBody>
+      </p:sp>
+      <p:sp>
+        <p:nvSpPr>
+          <p:cNvPr id="25" name="Rectangle 24"/>
+          <p:cNvSpPr/>
+          <p:nvPr/>
+        </p:nvSpPr>
+        <p:spPr>
+          <a:xfrm>
+            <a:off x="292608" y="4023360"/>
+            <a:ext cx="5541264" cy="411480"/>
+          </a:xfrm>
+          <a:prstGeom prst="rect">
+            <a:avLst/>
+          </a:prstGeom>
+          <a:solidFill>
+            <a:srgbClr val="0D1B2A"/>
+          </a:solidFill>
+          <a:ln>
+            <a:noFill/>
+          </a:ln>
+        </p:spPr>
+        <p:style>
+          <a:lnRef idx="1">
+            <a:schemeClr val="accent1"/>
+          </a:lnRef>
+          <a:fillRef idx="3">
+            <a:schemeClr val="accent1"/>
+          </a:fillRef>
+          <a:effectRef idx="2">
+            <a:schemeClr val="accent1"/>
+          </a:effectRef>
+          <a:fontRef idx="minor">
+            <a:schemeClr val="lt1"/>
+          </a:fontRef>
+        </p:style>
+        <p:txBody>
+          <a:bodyPr rtlCol="0" anchor="ctr"/>
+          <a:lstStyle/>
+          <a:p>
+            <a:pPr algn="ctr"/>
+          </a:p>
+        </p:txBody>
+      </p:sp>
+      <p:sp>
+        <p:nvSpPr>
+          <p:cNvPr id="26" name="TextBox 25"/>
+          <p:cNvSpPr txBox="1"/>
+          <p:nvPr/>
+        </p:nvSpPr>
+        <p:spPr>
+          <a:xfrm>
+            <a:off x="411480" y="4069080"/>
+            <a:ext cx="3154680" cy="329184"/>
+          </a:xfrm>
+          <a:prstGeom prst="rect">
+            <a:avLst/>
+          </a:prstGeom>
+          <a:noFill/>
+        </p:spPr>
+        <p:txBody>
+          <a:bodyPr wrap="square">
+            <a:spAutoFit/>
+          </a:bodyPr>
+          <a:lstStyle/>
+          <a:p>
+            <a:pPr algn="l"/>
+            <a:r>
+              <a:rPr sz="1100" b="0" i="0">
+                <a:solidFill>
+                  <a:srgbClr val="E0E0E0"/>
+                </a:solidFill>
+              </a:rPr>
+              <a:t>Tool calls (write 4 files)</a:t>
+            </a:r>
+          </a:p>
+        </p:txBody>
+      </p:sp>
+      <p:sp>
+        <p:nvSpPr>
+          <p:cNvPr id="27" name="TextBox 26"/>
+          <p:cNvSpPr txBox="1"/>
+          <p:nvPr/>
+        </p:nvSpPr>
+        <p:spPr>
+          <a:xfrm>
+            <a:off x="3657600" y="4069080"/>
+            <a:ext cx="1280160" cy="329184"/>
+          </a:xfrm>
+          <a:prstGeom prst="rect">
+            <a:avLst/>
+          </a:prstGeom>
+          <a:noFill/>
+        </p:spPr>
+        <p:txBody>
+          <a:bodyPr wrap="square">
+            <a:spAutoFit/>
+          </a:bodyPr>
+          <a:lstStyle/>
+          <a:p>
+            <a:pPr algn="r"/>
+            <a:r>
+              <a:rPr sz="1100" b="0" i="0">
+                <a:solidFill>
+                  <a:srgbClr val="FFFFFF"/>
+                </a:solidFill>
+              </a:rPr>
+              <a:t>~900 tokens</a:t>
+            </a:r>
+          </a:p>
+        </p:txBody>
+      </p:sp>
+      <p:sp>
+        <p:nvSpPr>
+          <p:cNvPr id="28" name="TextBox 27"/>
+          <p:cNvSpPr txBox="1"/>
+          <p:nvPr/>
+        </p:nvSpPr>
+        <p:spPr>
+          <a:xfrm>
+            <a:off x="4983480" y="4069080"/>
+            <a:ext cx="822960" cy="329184"/>
+          </a:xfrm>
+          <a:prstGeom prst="rect">
+            <a:avLst/>
+          </a:prstGeom>
+          <a:noFill/>
+        </p:spPr>
+        <p:txBody>
+          <a:bodyPr wrap="square">
+            <a:spAutoFit/>
+          </a:bodyPr>
+          <a:lstStyle/>
+          <a:p>
+            <a:pPr algn="l"/>
+            <a:r>
+              <a:rPr sz="900" b="0" i="0">
+                <a:solidFill>
+                  <a:srgbClr val="709070"/>
+                </a:solidFill>
+              </a:rPr>
+              <a:t>input side</a:t>
+            </a:r>
+          </a:p>
+        </p:txBody>
+      </p:sp>
+      <p:sp>
+        <p:nvSpPr>
+          <p:cNvPr id="29" name="Rectangle 28"/>
+          <p:cNvSpPr/>
+          <p:nvPr/>
+        </p:nvSpPr>
+        <p:spPr>
+          <a:xfrm>
+            <a:off x="292608" y="4462272"/>
+            <a:ext cx="5541264" cy="411480"/>
+          </a:xfrm>
+          <a:prstGeom prst="rect">
+            <a:avLst/>
+          </a:prstGeom>
+          <a:solidFill>
+            <a:srgbClr val="122030"/>
+          </a:solidFill>
+          <a:ln>
+            <a:noFill/>
+          </a:ln>
+        </p:spPr>
+        <p:style>
+          <a:lnRef idx="1">
+            <a:schemeClr val="accent1"/>
+          </a:lnRef>
+          <a:fillRef idx="3">
+            <a:schemeClr val="accent1"/>
+          </a:fillRef>
+          <a:effectRef idx="2">
+            <a:schemeClr val="accent1"/>
+          </a:effectRef>
+          <a:fontRef idx="minor">
+            <a:schemeClr val="lt1"/>
+          </a:fontRef>
+        </p:style>
+        <p:txBody>
+          <a:bodyPr rtlCol="0" anchor="ctr"/>
+          <a:lstStyle/>
+          <a:p>
+            <a:pPr algn="ctr"/>
+          </a:p>
+        </p:txBody>
+      </p:sp>
+      <p:sp>
+        <p:nvSpPr>
+          <p:cNvPr id="30" name="TextBox 29"/>
+          <p:cNvSpPr txBox="1"/>
+          <p:nvPr/>
+        </p:nvSpPr>
+        <p:spPr>
+          <a:xfrm>
+            <a:off x="411480" y="4507992"/>
+            <a:ext cx="3154680" cy="329184"/>
+          </a:xfrm>
+          <a:prstGeom prst="rect">
+            <a:avLst/>
+          </a:prstGeom>
+          <a:noFill/>
+        </p:spPr>
+        <p:txBody>
+          <a:bodyPr wrap="square">
+            <a:spAutoFit/>
+          </a:bodyPr>
+          <a:lstStyle/>
+          <a:p>
+            <a:pPr algn="l"/>
+            <a:r>
+              <a:rPr sz="1100" b="1" i="0">
+                <a:solidFill>
+                  <a:srgbClr val="E88C03"/>
+                </a:solidFill>
+              </a:rPr>
+              <a:t>Total input tokens</a:t>
+            </a:r>
+          </a:p>
+        </p:txBody>
+      </p:sp>
+      <p:sp>
+        <p:nvSpPr>
+          <p:cNvPr id="31" name="TextBox 30"/>
+          <p:cNvSpPr txBox="1"/>
+          <p:nvPr/>
+        </p:nvSpPr>
+        <p:spPr>
+          <a:xfrm>
+            <a:off x="3657600" y="4507992"/>
+            <a:ext cx="1280160" cy="329184"/>
+          </a:xfrm>
+          <a:prstGeom prst="rect">
+            <a:avLst/>
+          </a:prstGeom>
+          <a:noFill/>
+        </p:spPr>
+        <p:txBody>
+          <a:bodyPr wrap="square">
+            <a:spAutoFit/>
+          </a:bodyPr>
+          <a:lstStyle/>
+          <a:p>
+            <a:pPr algn="r"/>
+            <a:r>
+              <a:rPr sz="1100" b="1" i="0">
+                <a:solidFill>
+                  <a:srgbClr val="FFFFFF"/>
+                </a:solidFill>
+              </a:rPr>
+              <a:t>~5,020 tokens</a:t>
+            </a:r>
+          </a:p>
+        </p:txBody>
+      </p:sp>
+      <p:sp>
+        <p:nvSpPr>
+          <p:cNvPr id="32" name="TextBox 31"/>
+          <p:cNvSpPr txBox="1"/>
+          <p:nvPr/>
+        </p:nvSpPr>
+        <p:spPr>
+          <a:xfrm>
+            <a:off x="4983480" y="4507992"/>
+            <a:ext cx="822960" cy="329184"/>
+          </a:xfrm>
+          <a:prstGeom prst="rect">
+            <a:avLst/>
+          </a:prstGeom>
+          <a:noFill/>
+        </p:spPr>
+        <p:txBody>
+          <a:bodyPr wrap="square">
+            <a:spAutoFit/>
+          </a:bodyPr>
+          <a:lstStyle/>
+          <a:p>
+            <a:pPr algn="l"/>
+            <a:r>
+              <a:rPr sz="900" b="0" i="0">
+                <a:solidFill>
+                  <a:srgbClr val="709070"/>
+                </a:solidFill>
+              </a:rPr>
+              <a:t>1,200 cached</a:t>
+            </a:r>
+          </a:p>
+        </p:txBody>
+      </p:sp>
+      <p:sp>
+        <p:nvSpPr>
+          <p:cNvPr id="33" name="Rectangle 32"/>
+          <p:cNvSpPr/>
+          <p:nvPr/>
+        </p:nvSpPr>
+        <p:spPr>
+          <a:xfrm>
+            <a:off x="292608" y="4901183"/>
+            <a:ext cx="5541264" cy="411480"/>
+          </a:xfrm>
+          <a:prstGeom prst="rect">
+            <a:avLst/>
+          </a:prstGeom>
+          <a:solidFill>
+            <a:srgbClr val="0D1B2A"/>
+          </a:solidFill>
+          <a:ln>
+            <a:noFill/>
+          </a:ln>
+        </p:spPr>
+        <p:style>
+          <a:lnRef idx="1">
+            <a:schemeClr val="accent1"/>
+          </a:lnRef>
+          <a:fillRef idx="3">
+            <a:schemeClr val="accent1"/>
+          </a:fillRef>
+          <a:effectRef idx="2">
+            <a:schemeClr val="accent1"/>
+          </a:effectRef>
+          <a:fontRef idx="minor">
+            <a:schemeClr val="lt1"/>
+          </a:fontRef>
+        </p:style>
+        <p:txBody>
+          <a:bodyPr rtlCol="0" anchor="ctr"/>
+          <a:lstStyle/>
+          <a:p>
+            <a:pPr algn="ctr"/>
+          </a:p>
+        </p:txBody>
+      </p:sp>
+      <p:sp>
+        <p:nvSpPr>
+          <p:cNvPr id="34" name="TextBox 33"/>
+          <p:cNvSpPr txBox="1"/>
+          <p:nvPr/>
+        </p:nvSpPr>
+        <p:spPr>
+          <a:xfrm>
+            <a:off x="411480" y="4946903"/>
+            <a:ext cx="3154680" cy="329184"/>
+          </a:xfrm>
+          <a:prstGeom prst="rect">
+            <a:avLst/>
+          </a:prstGeom>
+          <a:noFill/>
+        </p:spPr>
+        <p:txBody>
+          <a:bodyPr wrap="square">
+            <a:spAutoFit/>
+          </a:bodyPr>
+          <a:lstStyle/>
+          <a:p>
+            <a:pPr algn="l"/>
+            <a:r>
+              <a:rPr sz="1100" b="1" i="0">
+                <a:solidFill>
+                  <a:srgbClr val="E88C03"/>
+                </a:solidFill>
+              </a:rPr>
+              <a:t>Total output tokens</a:t>
+            </a:r>
+          </a:p>
+        </p:txBody>
+      </p:sp>
+      <p:sp>
+        <p:nvSpPr>
+          <p:cNvPr id="35" name="TextBox 34"/>
+          <p:cNvSpPr txBox="1"/>
+          <p:nvPr/>
+        </p:nvSpPr>
+        <p:spPr>
+          <a:xfrm>
+            <a:off x="3657600" y="4946903"/>
+            <a:ext cx="1280160" cy="329184"/>
+          </a:xfrm>
+          <a:prstGeom prst="rect">
+            <a:avLst/>
+          </a:prstGeom>
+          <a:noFill/>
+        </p:spPr>
+        <p:txBody>
+          <a:bodyPr wrap="square">
+            <a:spAutoFit/>
+          </a:bodyPr>
+          <a:lstStyle/>
+          <a:p>
+            <a:pPr algn="r"/>
+            <a:r>
+              <a:rPr sz="1100" b="1" i="0">
+                <a:solidFill>
+                  <a:srgbClr val="FFFFFF"/>
+                </a:solidFill>
+              </a:rPr>
+              <a:t>~3,500 tokens</a:t>
+            </a:r>
+          </a:p>
+        </p:txBody>
+      </p:sp>
+      <p:sp>
+        <p:nvSpPr>
+          <p:cNvPr id="36" name="TextBox 35"/>
+          <p:cNvSpPr txBox="1"/>
+          <p:nvPr/>
+        </p:nvSpPr>
+        <p:spPr>
+          <a:xfrm>
+            <a:off x="4983480" y="4946903"/>
+            <a:ext cx="822960" cy="329184"/>
+          </a:xfrm>
+          <a:prstGeom prst="rect">
+            <a:avLst/>
+          </a:prstGeom>
+          <a:noFill/>
+        </p:spPr>
+        <p:txBody>
+          <a:bodyPr wrap="square">
+            <a:spAutoFit/>
+          </a:bodyPr>
+          <a:lstStyle/>
+          <a:p>
+            <a:pPr algn="l"/>
+            <a:r>
+              <a:rPr sz="900" b="0" i="0">
+                <a:solidFill>
+                  <a:srgbClr val="709070"/>
+                </a:solidFill>
+              </a:rPr>
+              <a:t/>
+            </a:r>
+          </a:p>
+        </p:txBody>
+      </p:sp>
+      <p:sp>
+        <p:nvSpPr>
+          <p:cNvPr id="37" name="Rectangle 36"/>
+          <p:cNvSpPr/>
+          <p:nvPr/>
+        </p:nvSpPr>
+        <p:spPr>
+          <a:xfrm>
+            <a:off x="292608" y="5349240"/>
+            <a:ext cx="5541264" cy="475488"/>
+          </a:xfrm>
+          <a:prstGeom prst="rect">
+            <a:avLst/>
+          </a:prstGeom>
+          <a:solidFill>
+            <a:srgbClr val="051830"/>
+          </a:solidFill>
+          <a:ln w="12700">
+            <a:solidFill>
+              <a:srgbClr val="1E90FF"/>
+            </a:solidFill>
+          </a:ln>
+        </p:spPr>
+        <p:style>
+          <a:lnRef idx="1">
+            <a:schemeClr val="accent1"/>
+          </a:lnRef>
+          <a:fillRef idx="3">
+            <a:schemeClr val="accent1"/>
+          </a:fillRef>
+          <a:effectRef idx="2">
+            <a:schemeClr val="accent1"/>
+          </a:effectRef>
+          <a:fontRef idx="minor">
+            <a:schemeClr val="lt1"/>
+          </a:fontRef>
+        </p:style>
+        <p:txBody>
+          <a:bodyPr rtlCol="0" anchor="ctr"/>
+          <a:lstStyle/>
+          <a:p>
+            <a:pPr algn="ctr"/>
+          </a:p>
+        </p:txBody>
+      </p:sp>
+      <p:sp>
+        <p:nvSpPr>
+          <p:cNvPr id="38" name="TextBox 37"/>
+          <p:cNvSpPr txBox="1"/>
+          <p:nvPr/>
+        </p:nvSpPr>
+        <p:spPr>
+          <a:xfrm>
+            <a:off x="411480" y="5394960"/>
+            <a:ext cx="2286000" cy="347472"/>
+          </a:xfrm>
+          <a:prstGeom prst="rect">
+            <a:avLst/>
+          </a:prstGeom>
+          <a:noFill/>
+        </p:spPr>
+        <p:txBody>
+          <a:bodyPr wrap="square">
+            <a:spAutoFit/>
+          </a:bodyPr>
+          <a:lstStyle/>
+          <a:p>
+            <a:pPr algn="l"/>
+            <a:r>
+              <a:rPr sz="1250" b="1" i="0">
+                <a:solidFill>
+                  <a:srgbClr val="1E90FF"/>
+                </a:solidFill>
+              </a:rPr>
+              <a:t>💰  Est. Cost:</a:t>
+            </a:r>
+          </a:p>
+        </p:txBody>
+      </p:sp>
+      <p:sp>
+        <p:nvSpPr>
+          <p:cNvPr id="39" name="TextBox 38"/>
+          <p:cNvSpPr txBox="1"/>
+          <p:nvPr/>
+        </p:nvSpPr>
+        <p:spPr>
+          <a:xfrm>
+            <a:off x="2560320" y="5394960"/>
+            <a:ext cx="3200400" cy="347472"/>
+          </a:xfrm>
+          <a:prstGeom prst="rect">
+            <a:avLst/>
+          </a:prstGeom>
+          <a:noFill/>
+        </p:spPr>
+        <p:txBody>
+          <a:bodyPr wrap="square">
+            <a:spAutoFit/>
+          </a:bodyPr>
+          <a:lstStyle/>
+          <a:p>
+            <a:pPr algn="l"/>
+            <a:r>
+              <a:rPr sz="1250" b="1" i="0">
+                <a:solidFill>
+                  <a:srgbClr val="FFFFFF"/>
+                </a:solidFill>
+              </a:rPr>
+              <a:t>~$0.09  (with prompt cache)</a:t>
+            </a:r>
+          </a:p>
+        </p:txBody>
+      </p:sp>
+      <p:sp>
+        <p:nvSpPr>
+          <p:cNvPr id="40" name="Rectangle 39"/>
+          <p:cNvSpPr/>
+          <p:nvPr/>
+        </p:nvSpPr>
+        <p:spPr>
+          <a:xfrm>
+            <a:off x="6492240" y="1737360"/>
+            <a:ext cx="5577840" cy="4160520"/>
+          </a:xfrm>
+          <a:prstGeom prst="rect">
+            <a:avLst/>
+          </a:prstGeom>
+          <a:solidFill>
+            <a:srgbClr val="1A2B3C"/>
+          </a:solidFill>
+          <a:ln w="19050">
+            <a:solidFill>
+              <a:srgbClr val="2ECC71"/>
+            </a:solidFill>
+          </a:ln>
+        </p:spPr>
+        <p:style>
+          <a:lnRef idx="1">
+            <a:schemeClr val="accent1"/>
+          </a:lnRef>
+          <a:fillRef idx="3">
+            <a:schemeClr val="accent1"/>
+          </a:fillRef>
+          <a:effectRef idx="2">
+            <a:schemeClr val="accent1"/>
+          </a:effectRef>
+          <a:fontRef idx="minor">
+            <a:schemeClr val="lt1"/>
+          </a:fontRef>
+        </p:style>
+        <p:txBody>
+          <a:bodyPr rtlCol="0" anchor="ctr"/>
+          <a:lstStyle/>
+          <a:p>
+            <a:pPr algn="ctr"/>
+          </a:p>
+        </p:txBody>
+      </p:sp>
+      <p:sp>
+        <p:nvSpPr>
+          <p:cNvPr id="41" name="TextBox 40"/>
+          <p:cNvSpPr txBox="1"/>
+          <p:nvPr/>
+        </p:nvSpPr>
+        <p:spPr>
+          <a:xfrm>
+            <a:off x="6675120" y="1783080"/>
+            <a:ext cx="5303520" cy="411480"/>
+          </a:xfrm>
+          <a:prstGeom prst="rect">
+            <a:avLst/>
+          </a:prstGeom>
+          <a:noFill/>
+        </p:spPr>
+        <p:txBody>
+          <a:bodyPr wrap="square">
+            <a:spAutoFit/>
+          </a:bodyPr>
+          <a:lstStyle/>
+          <a:p>
+            <a:pPr algn="l"/>
+            <a:r>
+              <a:rPr sz="1400" b="1" i="0">
+                <a:solidFill>
+                  <a:srgbClr val="2ECC71"/>
+                </a:solidFill>
+              </a:rPr>
+              <a:t>💻  IDE — Claude Sonnet 4.6</a:t>
+            </a:r>
+          </a:p>
+        </p:txBody>
+      </p:sp>
+      <p:sp>
+        <p:nvSpPr>
+          <p:cNvPr id="42" name="Rectangle 41"/>
+          <p:cNvSpPr/>
+          <p:nvPr/>
+        </p:nvSpPr>
+        <p:spPr>
+          <a:xfrm>
+            <a:off x="6510528" y="2267712"/>
+            <a:ext cx="5541264" cy="411480"/>
+          </a:xfrm>
+          <a:prstGeom prst="rect">
+            <a:avLst/>
+          </a:prstGeom>
+          <a:solidFill>
+            <a:srgbClr val="0D1B2A"/>
+          </a:solidFill>
+          <a:ln>
+            <a:noFill/>
+          </a:ln>
+        </p:spPr>
+        <p:style>
+          <a:lnRef idx="1">
+            <a:schemeClr val="accent1"/>
+          </a:lnRef>
+          <a:fillRef idx="3">
+            <a:schemeClr val="accent1"/>
+          </a:fillRef>
+          <a:effectRef idx="2">
+            <a:schemeClr val="accent1"/>
+          </a:effectRef>
+          <a:fontRef idx="minor">
+            <a:schemeClr val="lt1"/>
+          </a:fontRef>
+        </p:style>
+        <p:txBody>
+          <a:bodyPr rtlCol="0" anchor="ctr"/>
+          <a:lstStyle/>
+          <a:p>
+            <a:pPr algn="ctr"/>
+          </a:p>
+        </p:txBody>
+      </p:sp>
+      <p:sp>
+        <p:nvSpPr>
+          <p:cNvPr id="43" name="TextBox 42"/>
+          <p:cNvSpPr txBox="1"/>
+          <p:nvPr/>
+        </p:nvSpPr>
+        <p:spPr>
+          <a:xfrm>
+            <a:off x="6629400" y="2313432"/>
+            <a:ext cx="3154680" cy="329184"/>
+          </a:xfrm>
+          <a:prstGeom prst="rect">
+            <a:avLst/>
+          </a:prstGeom>
+          <a:noFill/>
+        </p:spPr>
+        <p:txBody>
+          <a:bodyPr wrap="square">
+            <a:spAutoFit/>
+          </a:bodyPr>
+          <a:lstStyle/>
+          <a:p>
+            <a:pPr algn="l"/>
+            <a:r>
+              <a:rPr sz="1100" b="0" i="0">
+                <a:solidFill>
+                  <a:srgbClr val="E0E0E0"/>
+                </a:solidFill>
+              </a:rPr>
+              <a:t>System prompt (per turn)</a:t>
+            </a:r>
+          </a:p>
+        </p:txBody>
+      </p:sp>
+      <p:sp>
+        <p:nvSpPr>
+          <p:cNvPr id="44" name="TextBox 43"/>
+          <p:cNvSpPr txBox="1"/>
+          <p:nvPr/>
+        </p:nvSpPr>
+        <p:spPr>
+          <a:xfrm>
+            <a:off x="9875520" y="2313432"/>
+            <a:ext cx="1280160" cy="329184"/>
+          </a:xfrm>
+          <a:prstGeom prst="rect">
+            <a:avLst/>
+          </a:prstGeom>
+          <a:noFill/>
+        </p:spPr>
+        <p:txBody>
+          <a:bodyPr wrap="square">
+            <a:spAutoFit/>
+          </a:bodyPr>
+          <a:lstStyle/>
+          <a:p>
+            <a:pPr algn="r"/>
+            <a:r>
+              <a:rPr sz="1100" b="0" i="0">
+                <a:solidFill>
+                  <a:srgbClr val="FFFFFF"/>
+                </a:solidFill>
+              </a:rPr>
+              <a:t>~1,200 tokens</a:t>
+            </a:r>
+          </a:p>
+        </p:txBody>
+      </p:sp>
+      <p:sp>
+        <p:nvSpPr>
+          <p:cNvPr id="45" name="TextBox 44"/>
+          <p:cNvSpPr txBox="1"/>
+          <p:nvPr/>
+        </p:nvSpPr>
+        <p:spPr>
+          <a:xfrm>
+            <a:off x="11201400" y="2313432"/>
+            <a:ext cx="777240" cy="329184"/>
+          </a:xfrm>
+          <a:prstGeom prst="rect">
+            <a:avLst/>
+          </a:prstGeom>
+          <a:noFill/>
+        </p:spPr>
+        <p:txBody>
+          <a:bodyPr wrap="square">
+            <a:spAutoFit/>
+          </a:bodyPr>
+          <a:lstStyle/>
+          <a:p>
+            <a:pPr algn="l"/>
+            <a:r>
+              <a:rPr sz="900" b="0" i="0">
+                <a:solidFill>
+                  <a:srgbClr val="709070"/>
+                </a:solidFill>
+              </a:rPr>
+              <a:t>cached (5-min TTL)</a:t>
+            </a:r>
+          </a:p>
+        </p:txBody>
+      </p:sp>
+      <p:sp>
+        <p:nvSpPr>
+          <p:cNvPr id="46" name="Rectangle 45"/>
+          <p:cNvSpPr/>
+          <p:nvPr/>
+        </p:nvSpPr>
+        <p:spPr>
+          <a:xfrm>
+            <a:off x="6510528" y="2706624"/>
+            <a:ext cx="5541264" cy="411480"/>
+          </a:xfrm>
+          <a:prstGeom prst="rect">
+            <a:avLst/>
+          </a:prstGeom>
+          <a:solidFill>
+            <a:srgbClr val="102215"/>
+          </a:solidFill>
+          <a:ln>
+            <a:noFill/>
+          </a:ln>
+        </p:spPr>
+        <p:style>
+          <a:lnRef idx="1">
+            <a:schemeClr val="accent1"/>
+          </a:lnRef>
+          <a:fillRef idx="3">
+            <a:schemeClr val="accent1"/>
+          </a:fillRef>
+          <a:effectRef idx="2">
+            <a:schemeClr val="accent1"/>
+          </a:effectRef>
+          <a:fontRef idx="minor">
+            <a:schemeClr val="lt1"/>
+          </a:fontRef>
+        </p:style>
+        <p:txBody>
+          <a:bodyPr rtlCol="0" anchor="ctr"/>
+          <a:lstStyle/>
+          <a:p>
+            <a:pPr algn="ctr"/>
+          </a:p>
+        </p:txBody>
+      </p:sp>
+      <p:sp>
+        <p:nvSpPr>
+          <p:cNvPr id="47" name="TextBox 46"/>
+          <p:cNvSpPr txBox="1"/>
+          <p:nvPr/>
+        </p:nvSpPr>
+        <p:spPr>
+          <a:xfrm>
+            <a:off x="6629400" y="2752344"/>
+            <a:ext cx="3154680" cy="329184"/>
+          </a:xfrm>
+          <a:prstGeom prst="rect">
+            <a:avLst/>
+          </a:prstGeom>
+          <a:noFill/>
+        </p:spPr>
+        <p:txBody>
+          <a:bodyPr wrap="square">
+            <a:spAutoFit/>
+          </a:bodyPr>
+          <a:lstStyle/>
+          <a:p>
+            <a:pPr algn="l"/>
+            <a:r>
+              <a:rPr sz="1100" b="0" i="0">
+                <a:solidFill>
+                  <a:srgbClr val="E0E0E0"/>
+                </a:solidFill>
+              </a:rPr>
+              <a:t>User prompt</a:t>
+            </a:r>
+          </a:p>
+        </p:txBody>
+      </p:sp>
+      <p:sp>
+        <p:nvSpPr>
+          <p:cNvPr id="48" name="TextBox 47"/>
+          <p:cNvSpPr txBox="1"/>
+          <p:nvPr/>
+        </p:nvSpPr>
+        <p:spPr>
+          <a:xfrm>
+            <a:off x="9875520" y="2752344"/>
+            <a:ext cx="1280160" cy="329184"/>
+          </a:xfrm>
+          <a:prstGeom prst="rect">
+            <a:avLst/>
+          </a:prstGeom>
+          <a:noFill/>
+        </p:spPr>
+        <p:txBody>
+          <a:bodyPr wrap="square">
+            <a:spAutoFit/>
+          </a:bodyPr>
+          <a:lstStyle/>
+          <a:p>
+            <a:pPr algn="r"/>
+            <a:r>
+              <a:rPr sz="1100" b="0" i="0">
+                <a:solidFill>
+                  <a:srgbClr val="FFFFFF"/>
+                </a:solidFill>
+              </a:rPr>
+              <a:t>~320 tokens</a:t>
+            </a:r>
+          </a:p>
+        </p:txBody>
+      </p:sp>
+      <p:sp>
+        <p:nvSpPr>
+          <p:cNvPr id="49" name="TextBox 48"/>
+          <p:cNvSpPr txBox="1"/>
+          <p:nvPr/>
+        </p:nvSpPr>
+        <p:spPr>
+          <a:xfrm>
+            <a:off x="11201400" y="2752344"/>
+            <a:ext cx="777240" cy="329184"/>
+          </a:xfrm>
+          <a:prstGeom prst="rect">
+            <a:avLst/>
+          </a:prstGeom>
+          <a:noFill/>
+        </p:spPr>
+        <p:txBody>
+          <a:bodyPr wrap="square">
+            <a:spAutoFit/>
+          </a:bodyPr>
+          <a:lstStyle/>
+          <a:p>
+            <a:pPr algn="l"/>
+            <a:r>
+              <a:rPr sz="900" b="0" i="0">
+                <a:solidFill>
+                  <a:srgbClr val="709070"/>
+                </a:solidFill>
+              </a:rPr>
+              <a:t>one-time</a:t>
+            </a:r>
+          </a:p>
+        </p:txBody>
+      </p:sp>
+      <p:sp>
+        <p:nvSpPr>
+          <p:cNvPr id="50" name="Rectangle 49"/>
+          <p:cNvSpPr/>
+          <p:nvPr/>
+        </p:nvSpPr>
+        <p:spPr>
+          <a:xfrm>
+            <a:off x="6510528" y="3145536"/>
+            <a:ext cx="5541264" cy="411480"/>
+          </a:xfrm>
+          <a:prstGeom prst="rect">
+            <a:avLst/>
+          </a:prstGeom>
+          <a:solidFill>
+            <a:srgbClr val="0D1B2A"/>
+          </a:solidFill>
+          <a:ln>
+            <a:noFill/>
+          </a:ln>
+        </p:spPr>
+        <p:style>
+          <a:lnRef idx="1">
+            <a:schemeClr val="accent1"/>
+          </a:lnRef>
+          <a:fillRef idx="3">
+            <a:schemeClr val="accent1"/>
+          </a:fillRef>
+          <a:effectRef idx="2">
+            <a:schemeClr val="accent1"/>
+          </a:effectRef>
+          <a:fontRef idx="minor">
+            <a:schemeClr val="lt1"/>
+          </a:fontRef>
+        </p:style>
+        <p:txBody>
+          <a:bodyPr rtlCol="0" anchor="ctr"/>
+          <a:lstStyle/>
+          <a:p>
+            <a:pPr algn="ctr"/>
+          </a:p>
+        </p:txBody>
+      </p:sp>
+      <p:sp>
+        <p:nvSpPr>
+          <p:cNvPr id="51" name="TextBox 50"/>
+          <p:cNvSpPr txBox="1"/>
+          <p:nvPr/>
+        </p:nvSpPr>
+        <p:spPr>
+          <a:xfrm>
+            <a:off x="6629400" y="3191256"/>
+            <a:ext cx="3154680" cy="329184"/>
+          </a:xfrm>
+          <a:prstGeom prst="rect">
+            <a:avLst/>
+          </a:prstGeom>
+          <a:noFill/>
+        </p:spPr>
+        <p:txBody>
+          <a:bodyPr wrap="square">
+            <a:spAutoFit/>
+          </a:bodyPr>
+          <a:lstStyle/>
+          <a:p>
+            <a:pPr algn="l"/>
+            <a:r>
+              <a:rPr sz="1100" b="0" i="0">
+                <a:solidFill>
+                  <a:srgbClr val="E0E0E0"/>
+                </a:solidFill>
+              </a:rPr>
+              <a:t>File context (read 6 files)</a:t>
+            </a:r>
+          </a:p>
+        </p:txBody>
+      </p:sp>
+      <p:sp>
+        <p:nvSpPr>
+          <p:cNvPr id="52" name="TextBox 51"/>
+          <p:cNvSpPr txBox="1"/>
+          <p:nvPr/>
+        </p:nvSpPr>
+        <p:spPr>
+          <a:xfrm>
+            <a:off x="9875520" y="3191256"/>
+            <a:ext cx="1280160" cy="329184"/>
+          </a:xfrm>
+          <a:prstGeom prst="rect">
+            <a:avLst/>
+          </a:prstGeom>
+          <a:noFill/>
+        </p:spPr>
+        <p:txBody>
+          <a:bodyPr wrap="square">
+            <a:spAutoFit/>
+          </a:bodyPr>
+          <a:lstStyle/>
+          <a:p>
+            <a:pPr algn="r"/>
+            <a:r>
+              <a:rPr sz="1100" b="0" i="0">
+                <a:solidFill>
+                  <a:srgbClr val="FFFFFF"/>
+                </a:solidFill>
+              </a:rPr>
+              <a:t>~4,200 tokens</a:t>
+            </a:r>
+          </a:p>
+        </p:txBody>
+      </p:sp>
+      <p:sp>
+        <p:nvSpPr>
+          <p:cNvPr id="53" name="TextBox 52"/>
+          <p:cNvSpPr txBox="1"/>
+          <p:nvPr/>
+        </p:nvSpPr>
+        <p:spPr>
+          <a:xfrm>
+            <a:off x="11201400" y="3191256"/>
+            <a:ext cx="777240" cy="329184"/>
+          </a:xfrm>
+          <a:prstGeom prst="rect">
+            <a:avLst/>
+          </a:prstGeom>
+          <a:noFill/>
+        </p:spPr>
+        <p:txBody>
+          <a:bodyPr wrap="square">
+            <a:spAutoFit/>
+          </a:bodyPr>
+          <a:lstStyle/>
+          <a:p>
+            <a:pPr algn="l"/>
+            <a:r>
+              <a:rPr sz="900" b="0" i="0">
+                <a:solidFill>
+                  <a:srgbClr val="709070"/>
+                </a:solidFill>
+              </a:rPr>
+              <a:t>cached after 1st read</a:t>
+            </a:r>
+          </a:p>
+        </p:txBody>
+      </p:sp>
+      <p:sp>
+        <p:nvSpPr>
+          <p:cNvPr id="54" name="Rectangle 53"/>
+          <p:cNvSpPr/>
+          <p:nvPr/>
+        </p:nvSpPr>
+        <p:spPr>
+          <a:xfrm>
+            <a:off x="6510528" y="3584448"/>
+            <a:ext cx="5541264" cy="411480"/>
+          </a:xfrm>
+          <a:prstGeom prst="rect">
+            <a:avLst/>
+          </a:prstGeom>
+          <a:solidFill>
+            <a:srgbClr val="102215"/>
+          </a:solidFill>
+          <a:ln>
+            <a:noFill/>
+          </a:ln>
+        </p:spPr>
+        <p:style>
+          <a:lnRef idx="1">
+            <a:schemeClr val="accent1"/>
+          </a:lnRef>
+          <a:fillRef idx="3">
+            <a:schemeClr val="accent1"/>
+          </a:fillRef>
+          <a:effectRef idx="2">
+            <a:schemeClr val="accent1"/>
+          </a:effectRef>
+          <a:fontRef idx="minor">
+            <a:schemeClr val="lt1"/>
+          </a:fontRef>
+        </p:style>
+        <p:txBody>
+          <a:bodyPr rtlCol="0" anchor="ctr"/>
+          <a:lstStyle/>
+          <a:p>
+            <a:pPr algn="ctr"/>
+          </a:p>
+        </p:txBody>
+      </p:sp>
+      <p:sp>
+        <p:nvSpPr>
+          <p:cNvPr id="55" name="TextBox 54"/>
+          <p:cNvSpPr txBox="1"/>
+          <p:nvPr/>
+        </p:nvSpPr>
+        <p:spPr>
+          <a:xfrm>
+            <a:off x="6629400" y="3630168"/>
+            <a:ext cx="3154680" cy="329184"/>
+          </a:xfrm>
+          <a:prstGeom prst="rect">
+            <a:avLst/>
+          </a:prstGeom>
+          <a:noFill/>
+        </p:spPr>
+        <p:txBody>
+          <a:bodyPr wrap="square">
+            <a:spAutoFit/>
+          </a:bodyPr>
+          <a:lstStyle/>
+          <a:p>
+            <a:pPr algn="l"/>
+            <a:r>
+              <a:rPr sz="1100" b="0" i="0">
+                <a:solidFill>
+                  <a:srgbClr val="E0E0E0"/>
+                </a:solidFill>
+              </a:rPr>
+              <a:t>Model output (code + explain)</a:t>
+            </a:r>
+          </a:p>
+        </p:txBody>
+      </p:sp>
+      <p:sp>
+        <p:nvSpPr>
+          <p:cNvPr id="56" name="TextBox 55"/>
+          <p:cNvSpPr txBox="1"/>
+          <p:nvPr/>
+        </p:nvSpPr>
+        <p:spPr>
+          <a:xfrm>
+            <a:off x="9875520" y="3630168"/>
+            <a:ext cx="1280160" cy="329184"/>
+          </a:xfrm>
+          <a:prstGeom prst="rect">
+            <a:avLst/>
+          </a:prstGeom>
+          <a:noFill/>
+        </p:spPr>
+        <p:txBody>
+          <a:bodyPr wrap="square">
+            <a:spAutoFit/>
+          </a:bodyPr>
+          <a:lstStyle/>
+          <a:p>
+            <a:pPr algn="r"/>
+            <a:r>
+              <a:rPr sz="1100" b="0" i="0">
+                <a:solidFill>
+                  <a:srgbClr val="FFFFFF"/>
+                </a:solidFill>
+              </a:rPr>
+              <a:t>~3,500 tokens</a:t>
+            </a:r>
+          </a:p>
+        </p:txBody>
+      </p:sp>
+      <p:sp>
+        <p:nvSpPr>
+          <p:cNvPr id="57" name="TextBox 56"/>
+          <p:cNvSpPr txBox="1"/>
+          <p:nvPr/>
+        </p:nvSpPr>
+        <p:spPr>
+          <a:xfrm>
+            <a:off x="11201400" y="3630168"/>
+            <a:ext cx="777240" cy="329184"/>
+          </a:xfrm>
+          <a:prstGeom prst="rect">
+            <a:avLst/>
+          </a:prstGeom>
+          <a:noFill/>
+        </p:spPr>
+        <p:txBody>
+          <a:bodyPr wrap="square">
+            <a:spAutoFit/>
+          </a:bodyPr>
+          <a:lstStyle/>
+          <a:p>
+            <a:pPr algn="l"/>
+            <a:r>
+              <a:rPr sz="900" b="0" i="0">
+                <a:solidFill>
+                  <a:srgbClr val="709070"/>
+                </a:solidFill>
+              </a:rPr>
+              <a:t>output, billed full</a:t>
+            </a:r>
+          </a:p>
+        </p:txBody>
+      </p:sp>
+      <p:sp>
+        <p:nvSpPr>
+          <p:cNvPr id="58" name="Rectangle 57"/>
+          <p:cNvSpPr/>
+          <p:nvPr/>
+        </p:nvSpPr>
+        <p:spPr>
+          <a:xfrm>
+            <a:off x="6510528" y="4023360"/>
+            <a:ext cx="5541264" cy="411480"/>
+          </a:xfrm>
+          <a:prstGeom prst="rect">
+            <a:avLst/>
+          </a:prstGeom>
+          <a:solidFill>
+            <a:srgbClr val="0D1B2A"/>
+          </a:solidFill>
+          <a:ln>
+            <a:noFill/>
+          </a:ln>
+        </p:spPr>
+        <p:style>
+          <a:lnRef idx="1">
+            <a:schemeClr val="accent1"/>
+          </a:lnRef>
+          <a:fillRef idx="3">
+            <a:schemeClr val="accent1"/>
+          </a:fillRef>
+          <a:effectRef idx="2">
+            <a:schemeClr val="accent1"/>
+          </a:effectRef>
+          <a:fontRef idx="minor">
+            <a:schemeClr val="lt1"/>
+          </a:fontRef>
+        </p:style>
+        <p:txBody>
+          <a:bodyPr rtlCol="0" anchor="ctr"/>
+          <a:lstStyle/>
+          <a:p>
+            <a:pPr algn="ctr"/>
+          </a:p>
+        </p:txBody>
+      </p:sp>
+      <p:sp>
+        <p:nvSpPr>
+          <p:cNvPr id="59" name="TextBox 58"/>
+          <p:cNvSpPr txBox="1"/>
+          <p:nvPr/>
+        </p:nvSpPr>
+        <p:spPr>
+          <a:xfrm>
+            <a:off x="6629400" y="4069080"/>
+            <a:ext cx="3154680" cy="329184"/>
+          </a:xfrm>
+          <a:prstGeom prst="rect">
+            <a:avLst/>
+          </a:prstGeom>
+          <a:noFill/>
+        </p:spPr>
+        <p:txBody>
+          <a:bodyPr wrap="square">
+            <a:spAutoFit/>
+          </a:bodyPr>
+          <a:lstStyle/>
+          <a:p>
+            <a:pPr algn="l"/>
+            <a:r>
+              <a:rPr sz="1100" b="0" i="0">
+                <a:solidFill>
+                  <a:srgbClr val="E0E0E0"/>
+                </a:solidFill>
+              </a:rPr>
+              <a:t>Tool calls (edit/write files)</a:t>
+            </a:r>
+          </a:p>
+        </p:txBody>
+      </p:sp>
+      <p:sp>
+        <p:nvSpPr>
+          <p:cNvPr id="60" name="TextBox 59"/>
+          <p:cNvSpPr txBox="1"/>
+          <p:nvPr/>
+        </p:nvSpPr>
+        <p:spPr>
+          <a:xfrm>
+            <a:off x="9875520" y="4069080"/>
+            <a:ext cx="1280160" cy="329184"/>
+          </a:xfrm>
+          <a:prstGeom prst="rect">
+            <a:avLst/>
+          </a:prstGeom>
+          <a:noFill/>
+        </p:spPr>
+        <p:txBody>
+          <a:bodyPr wrap="square">
+            <a:spAutoFit/>
+          </a:bodyPr>
+          <a:lstStyle/>
+          <a:p>
+            <a:pPr algn="r"/>
+            <a:r>
+              <a:rPr sz="1100" b="0" i="0">
+                <a:solidFill>
+                  <a:srgbClr val="FFFFFF"/>
+                </a:solidFill>
+              </a:rPr>
+              <a:t>~600 tokens</a:t>
+            </a:r>
+          </a:p>
+        </p:txBody>
+      </p:sp>
+      <p:sp>
+        <p:nvSpPr>
+          <p:cNvPr id="61" name="TextBox 60"/>
+          <p:cNvSpPr txBox="1"/>
+          <p:nvPr/>
+        </p:nvSpPr>
+        <p:spPr>
+          <a:xfrm>
+            <a:off x="11201400" y="4069080"/>
+            <a:ext cx="777240" cy="329184"/>
+          </a:xfrm>
+          <a:prstGeom prst="rect">
+            <a:avLst/>
+          </a:prstGeom>
+          <a:noFill/>
+        </p:spPr>
+        <p:txBody>
+          <a:bodyPr wrap="square">
+            <a:spAutoFit/>
+          </a:bodyPr>
+          <a:lstStyle/>
+          <a:p>
+            <a:pPr algn="l"/>
+            <a:r>
+              <a:rPr sz="900" b="0" i="0">
+                <a:solidFill>
+                  <a:srgbClr val="709070"/>
+                </a:solidFill>
+              </a:rPr>
+              <a:t>input side</a:t>
+            </a:r>
+          </a:p>
+        </p:txBody>
+      </p:sp>
+      <p:sp>
+        <p:nvSpPr>
+          <p:cNvPr id="62" name="Rectangle 61"/>
+          <p:cNvSpPr/>
+          <p:nvPr/>
+        </p:nvSpPr>
+        <p:spPr>
+          <a:xfrm>
+            <a:off x="6510528" y="4462272"/>
+            <a:ext cx="5541264" cy="411480"/>
+          </a:xfrm>
+          <a:prstGeom prst="rect">
+            <a:avLst/>
+          </a:prstGeom>
+          <a:solidFill>
+            <a:srgbClr val="102215"/>
+          </a:solidFill>
+          <a:ln>
+            <a:noFill/>
+          </a:ln>
+        </p:spPr>
+        <p:style>
+          <a:lnRef idx="1">
+            <a:schemeClr val="accent1"/>
+          </a:lnRef>
+          <a:fillRef idx="3">
+            <a:schemeClr val="accent1"/>
+          </a:fillRef>
+          <a:effectRef idx="2">
+            <a:schemeClr val="accent1"/>
+          </a:effectRef>
+          <a:fontRef idx="minor">
+            <a:schemeClr val="lt1"/>
+          </a:fontRef>
+        </p:style>
+        <p:txBody>
+          <a:bodyPr rtlCol="0" anchor="ctr"/>
+          <a:lstStyle/>
+          <a:p>
+            <a:pPr algn="ctr"/>
+          </a:p>
+        </p:txBody>
+      </p:sp>
+      <p:sp>
+        <p:nvSpPr>
+          <p:cNvPr id="63" name="TextBox 62"/>
+          <p:cNvSpPr txBox="1"/>
+          <p:nvPr/>
+        </p:nvSpPr>
+        <p:spPr>
+          <a:xfrm>
+            <a:off x="6629400" y="4507992"/>
+            <a:ext cx="3154680" cy="329184"/>
+          </a:xfrm>
+          <a:prstGeom prst="rect">
+            <a:avLst/>
+          </a:prstGeom>
+          <a:noFill/>
+        </p:spPr>
+        <p:txBody>
+          <a:bodyPr wrap="square">
+            <a:spAutoFit/>
+          </a:bodyPr>
+          <a:lstStyle/>
+          <a:p>
+            <a:pPr algn="l"/>
+            <a:r>
+              <a:rPr sz="1100" b="1" i="0">
+                <a:solidFill>
+                  <a:srgbClr val="E88C03"/>
+                </a:solidFill>
+              </a:rPr>
+              <a:t>Total input tokens</a:t>
+            </a:r>
+          </a:p>
+        </p:txBody>
+      </p:sp>
+      <p:sp>
+        <p:nvSpPr>
+          <p:cNvPr id="64" name="TextBox 63"/>
+          <p:cNvSpPr txBox="1"/>
+          <p:nvPr/>
+        </p:nvSpPr>
+        <p:spPr>
+          <a:xfrm>
+            <a:off x="9875520" y="4507992"/>
+            <a:ext cx="1280160" cy="329184"/>
+          </a:xfrm>
+          <a:prstGeom prst="rect">
+            <a:avLst/>
+          </a:prstGeom>
+          <a:noFill/>
+        </p:spPr>
+        <p:txBody>
+          <a:bodyPr wrap="square">
+            <a:spAutoFit/>
+          </a:bodyPr>
+          <a:lstStyle/>
+          <a:p>
+            <a:pPr algn="r"/>
+            <a:r>
+              <a:rPr sz="1100" b="1" i="0">
+                <a:solidFill>
+                  <a:srgbClr val="FFFFFF"/>
+                </a:solidFill>
+              </a:rPr>
+              <a:t>~6,320 tokens</a:t>
+            </a:r>
+          </a:p>
+        </p:txBody>
+      </p:sp>
+      <p:sp>
+        <p:nvSpPr>
+          <p:cNvPr id="65" name="TextBox 64"/>
+          <p:cNvSpPr txBox="1"/>
+          <p:nvPr/>
+        </p:nvSpPr>
+        <p:spPr>
+          <a:xfrm>
+            <a:off x="11201400" y="4507992"/>
+            <a:ext cx="777240" cy="329184"/>
+          </a:xfrm>
+          <a:prstGeom prst="rect">
+            <a:avLst/>
+          </a:prstGeom>
+          <a:noFill/>
+        </p:spPr>
+        <p:txBody>
+          <a:bodyPr wrap="square">
+            <a:spAutoFit/>
+          </a:bodyPr>
+          <a:lstStyle/>
+          <a:p>
+            <a:pPr algn="l"/>
+            <a:r>
+              <a:rPr sz="900" b="0" i="0">
+                <a:solidFill>
+                  <a:srgbClr val="709070"/>
+                </a:solidFill>
+              </a:rPr>
+              <a:t>5,400 cached</a:t>
+            </a:r>
+          </a:p>
+        </p:txBody>
+      </p:sp>
+      <p:sp>
+        <p:nvSpPr>
+          <p:cNvPr id="66" name="Rectangle 65"/>
+          <p:cNvSpPr/>
+          <p:nvPr/>
+        </p:nvSpPr>
+        <p:spPr>
+          <a:xfrm>
+            <a:off x="6510528" y="4901183"/>
+            <a:ext cx="5541264" cy="411480"/>
+          </a:xfrm>
+          <a:prstGeom prst="rect">
+            <a:avLst/>
+          </a:prstGeom>
+          <a:solidFill>
+            <a:srgbClr val="0D1B2A"/>
+          </a:solidFill>
+          <a:ln>
+            <a:noFill/>
+          </a:ln>
+        </p:spPr>
+        <p:style>
+          <a:lnRef idx="1">
+            <a:schemeClr val="accent1"/>
+          </a:lnRef>
+          <a:fillRef idx="3">
+            <a:schemeClr val="accent1"/>
+          </a:fillRef>
+          <a:effectRef idx="2">
+            <a:schemeClr val="accent1"/>
+          </a:effectRef>
+          <a:fontRef idx="minor">
+            <a:schemeClr val="lt1"/>
+          </a:fontRef>
+        </p:style>
+        <p:txBody>
+          <a:bodyPr rtlCol="0" anchor="ctr"/>
+          <a:lstStyle/>
+          <a:p>
+            <a:pPr algn="ctr"/>
+          </a:p>
+        </p:txBody>
+      </p:sp>
+      <p:sp>
+        <p:nvSpPr>
+          <p:cNvPr id="67" name="TextBox 66"/>
+          <p:cNvSpPr txBox="1"/>
+          <p:nvPr/>
+        </p:nvSpPr>
+        <p:spPr>
+          <a:xfrm>
+            <a:off x="6629400" y="4946903"/>
+            <a:ext cx="3154680" cy="329184"/>
+          </a:xfrm>
+          <a:prstGeom prst="rect">
+            <a:avLst/>
+          </a:prstGeom>
+          <a:noFill/>
+        </p:spPr>
+        <p:txBody>
+          <a:bodyPr wrap="square">
+            <a:spAutoFit/>
+          </a:bodyPr>
+          <a:lstStyle/>
+          <a:p>
+            <a:pPr algn="l"/>
+            <a:r>
+              <a:rPr sz="1100" b="1" i="0">
+                <a:solidFill>
+                  <a:srgbClr val="E88C03"/>
+                </a:solidFill>
+              </a:rPr>
+              <a:t>Total output tokens</a:t>
+            </a:r>
+          </a:p>
+        </p:txBody>
+      </p:sp>
+      <p:sp>
+        <p:nvSpPr>
+          <p:cNvPr id="68" name="TextBox 67"/>
+          <p:cNvSpPr txBox="1"/>
+          <p:nvPr/>
+        </p:nvSpPr>
+        <p:spPr>
+          <a:xfrm>
+            <a:off x="9875520" y="4946903"/>
+            <a:ext cx="1280160" cy="329184"/>
+          </a:xfrm>
+          <a:prstGeom prst="rect">
+            <a:avLst/>
+          </a:prstGeom>
+          <a:noFill/>
+        </p:spPr>
+        <p:txBody>
+          <a:bodyPr wrap="square">
+            <a:spAutoFit/>
+          </a:bodyPr>
+          <a:lstStyle/>
+          <a:p>
+            <a:pPr algn="r"/>
+            <a:r>
+              <a:rPr sz="1100" b="1" i="0">
+                <a:solidFill>
+                  <a:srgbClr val="FFFFFF"/>
+                </a:solidFill>
+              </a:rPr>
+              <a:t>~3,500 tokens</a:t>
+            </a:r>
+          </a:p>
+        </p:txBody>
+      </p:sp>
+      <p:sp>
+        <p:nvSpPr>
+          <p:cNvPr id="69" name="TextBox 68"/>
+          <p:cNvSpPr txBox="1"/>
+          <p:nvPr/>
+        </p:nvSpPr>
+        <p:spPr>
+          <a:xfrm>
+            <a:off x="11201400" y="4946903"/>
+            <a:ext cx="777240" cy="329184"/>
+          </a:xfrm>
+          <a:prstGeom prst="rect">
+            <a:avLst/>
+          </a:prstGeom>
+          <a:noFill/>
+        </p:spPr>
+        <p:txBody>
+          <a:bodyPr wrap="square">
+            <a:spAutoFit/>
+          </a:bodyPr>
+          <a:lstStyle/>
+          <a:p>
+            <a:pPr algn="l"/>
+            <a:r>
+              <a:rPr sz="900" b="0" i="0">
+                <a:solidFill>
+                  <a:srgbClr val="709070"/>
+                </a:solidFill>
+              </a:rPr>
+              <a:t/>
+            </a:r>
+          </a:p>
+        </p:txBody>
+      </p:sp>
+      <p:sp>
+        <p:nvSpPr>
+          <p:cNvPr id="70" name="Rectangle 69"/>
+          <p:cNvSpPr/>
+          <p:nvPr/>
+        </p:nvSpPr>
+        <p:spPr>
+          <a:xfrm>
+            <a:off x="6510528" y="5349240"/>
+            <a:ext cx="5541264" cy="475488"/>
+          </a:xfrm>
+          <a:prstGeom prst="rect">
+            <a:avLst/>
+          </a:prstGeom>
+          <a:solidFill>
+            <a:srgbClr val="05200A"/>
+          </a:solidFill>
+          <a:ln w="12700">
+            <a:solidFill>
+              <a:srgbClr val="2ECC71"/>
+            </a:solidFill>
+          </a:ln>
+        </p:spPr>
+        <p:style>
+          <a:lnRef idx="1">
+            <a:schemeClr val="accent1"/>
+          </a:lnRef>
+          <a:fillRef idx="3">
+            <a:schemeClr val="accent1"/>
+          </a:fillRef>
+          <a:effectRef idx="2">
+            <a:schemeClr val="accent1"/>
+          </a:effectRef>
+          <a:fontRef idx="minor">
+            <a:schemeClr val="lt1"/>
+          </a:fontRef>
+        </p:style>
+        <p:txBody>
+          <a:bodyPr rtlCol="0" anchor="ctr"/>
+          <a:lstStyle/>
+          <a:p>
+            <a:pPr algn="ctr"/>
+          </a:p>
+        </p:txBody>
+      </p:sp>
+      <p:sp>
+        <p:nvSpPr>
+          <p:cNvPr id="71" name="TextBox 70"/>
+          <p:cNvSpPr txBox="1"/>
+          <p:nvPr/>
+        </p:nvSpPr>
+        <p:spPr>
+          <a:xfrm>
+            <a:off x="6629400" y="5394960"/>
+            <a:ext cx="2286000" cy="347472"/>
+          </a:xfrm>
+          <a:prstGeom prst="rect">
+            <a:avLst/>
+          </a:prstGeom>
+          <a:noFill/>
+        </p:spPr>
+        <p:txBody>
+          <a:bodyPr wrap="square">
+            <a:spAutoFit/>
+          </a:bodyPr>
+          <a:lstStyle/>
+          <a:p>
+            <a:pPr algn="l"/>
+            <a:r>
+              <a:rPr sz="1250" b="1" i="0">
+                <a:solidFill>
+                  <a:srgbClr val="2ECC71"/>
+                </a:solidFill>
+              </a:rPr>
+              <a:t>💰  Est. Cost:</a:t>
+            </a:r>
+          </a:p>
+        </p:txBody>
+      </p:sp>
+      <p:sp>
+        <p:nvSpPr>
+          <p:cNvPr id="72" name="TextBox 71"/>
+          <p:cNvSpPr txBox="1"/>
+          <p:nvPr/>
+        </p:nvSpPr>
+        <p:spPr>
+          <a:xfrm>
+            <a:off x="8778240" y="5394960"/>
+            <a:ext cx="3200400" cy="347472"/>
+          </a:xfrm>
+          <a:prstGeom prst="rect">
+            <a:avLst/>
+          </a:prstGeom>
+          <a:noFill/>
+        </p:spPr>
+        <p:txBody>
+          <a:bodyPr wrap="square">
+            <a:spAutoFit/>
+          </a:bodyPr>
+          <a:lstStyle/>
+          <a:p>
+            <a:pPr algn="l"/>
+            <a:r>
+              <a:rPr sz="1250" b="1" i="0">
+                <a:solidFill>
+                  <a:srgbClr val="FFFFFF"/>
+                </a:solidFill>
+              </a:rPr>
+              <a:t>~$0.055  (Sonnet + cache)</a:t>
+            </a:r>
+          </a:p>
+        </p:txBody>
+      </p:sp>
+      <p:sp>
+        <p:nvSpPr>
+          <p:cNvPr id="73" name="Rectangle 72"/>
+          <p:cNvSpPr/>
+          <p:nvPr/>
+        </p:nvSpPr>
+        <p:spPr>
+          <a:xfrm>
+            <a:off x="274320" y="5916168"/>
+            <a:ext cx="11640312" cy="685800"/>
+          </a:xfrm>
+          <a:prstGeom prst="rect">
+            <a:avLst/>
+          </a:prstGeom>
+          <a:solidFill>
+            <a:srgbClr val="1A1403"/>
+          </a:solidFill>
+          <a:ln w="19050">
+            <a:solidFill>
+              <a:srgbClr val="E88C03"/>
+            </a:solidFill>
+          </a:ln>
+        </p:spPr>
+        <p:style>
+          <a:lnRef idx="1">
+            <a:schemeClr val="accent1"/>
+          </a:lnRef>
+          <a:fillRef idx="3">
+            <a:schemeClr val="accent1"/>
+          </a:fillRef>
+          <a:effectRef idx="2">
+            <a:schemeClr val="accent1"/>
+          </a:effectRef>
+          <a:fontRef idx="minor">
+            <a:schemeClr val="lt1"/>
+          </a:fontRef>
+        </p:style>
+        <p:txBody>
+          <a:bodyPr rtlCol="0" anchor="ctr"/>
+          <a:lstStyle/>
+          <a:p>
+            <a:pPr algn="ctr"/>
+          </a:p>
+        </p:txBody>
+      </p:sp>
+      <p:sp>
+        <p:nvSpPr>
+          <p:cNvPr id="74" name="TextBox 73"/>
+          <p:cNvSpPr txBox="1"/>
+          <p:nvPr/>
+        </p:nvSpPr>
+        <p:spPr>
+          <a:xfrm>
+            <a:off x="457200" y="5989320"/>
+            <a:ext cx="11274552" cy="502920"/>
+          </a:xfrm>
+          <a:prstGeom prst="rect">
+            <a:avLst/>
+          </a:prstGeom>
+          <a:noFill/>
+        </p:spPr>
+        <p:txBody>
+          <a:bodyPr wrap="square">
+            <a:spAutoFit/>
+          </a:bodyPr>
+          <a:lstStyle/>
+          <a:p>
+            <a:pPr algn="ctr"/>
+            <a:r>
+              <a:rPr sz="1300" b="1" i="0">
+                <a:solidFill>
+                  <a:srgbClr val="E88C03"/>
+                </a:solidFill>
+              </a:rPr>
+              <a:t>🏆  IDE saves ~40% on this task  |  Repeat runs (cache warm): IDE ~$0.016  vs  Web ~$0.032  |  Batch mode: extra 50% off</a:t>
             </a:r>
           </a:p>
         </p:txBody>

</xml_diff>